<commit_message>
Fix PubMed slide chart clipping and add publish QA
</commit_message>
<xml_diff>
--- a/archive/2026-06-03/pubmed-dlbcl-cnsl-btki-2026-06-03.pptx
+++ b/archive/2026-06-03/pubmed-dlbcl-cnsl-btki-2026-06-03.pptx
@@ -4719,7 +4719,7 @@
         <p:spPr>
           <a:xfrm>
             <a:off x="6382512" y="1764792"/>
-            <a:ext cx="1554480" cy="237744"/>
+            <a:ext cx="1828800" cy="237744"/>
           </a:xfrm>
           <a:prstGeom prst="rect">
             <a:avLst/>
@@ -4734,7 +4734,7 @@
           <a:p>
             <a:pPr algn="l"/>
             <a:r>
-              <a:rPr sz="900" b="1">
+              <a:rPr sz="850" b="1">
                 <a:solidFill>
                   <a:srgbClr val="18212B"/>
                 </a:solidFill>
@@ -4753,8 +4753,8 @@
         </p:nvSpPr>
         <p:spPr>
           <a:xfrm>
-            <a:off x="7955279" y="1783080"/>
-            <a:ext cx="2606039" cy="146304"/>
+            <a:off x="8183879" y="1783080"/>
+            <a:ext cx="2240279" cy="146304"/>
           </a:xfrm>
           <a:prstGeom prst="rect">
             <a:avLst/>
@@ -4799,8 +4799,8 @@
         </p:nvSpPr>
         <p:spPr>
           <a:xfrm>
-            <a:off x="7955279" y="1783080"/>
-            <a:ext cx="453450" cy="146304"/>
+            <a:off x="8183879" y="1783080"/>
+            <a:ext cx="389808" cy="146304"/>
           </a:xfrm>
           <a:prstGeom prst="rect">
             <a:avLst/>
@@ -4845,8 +4845,8 @@
         </p:nvSpPr>
         <p:spPr>
           <a:xfrm>
-            <a:off x="10652759" y="1755648"/>
-            <a:ext cx="548640" cy="201168"/>
+            <a:off x="10469880" y="1755648"/>
+            <a:ext cx="731520" cy="201168"/>
           </a:xfrm>
           <a:prstGeom prst="rect">
             <a:avLst/>
@@ -4881,7 +4881,7 @@
         <p:spPr>
           <a:xfrm>
             <a:off x="6382512" y="2148840"/>
-            <a:ext cx="1554480" cy="237744"/>
+            <a:ext cx="1828800" cy="237744"/>
           </a:xfrm>
           <a:prstGeom prst="rect">
             <a:avLst/>
@@ -4896,7 +4896,7 @@
           <a:p>
             <a:pPr algn="l"/>
             <a:r>
-              <a:rPr sz="900" b="1">
+              <a:rPr sz="850" b="1">
                 <a:solidFill>
                   <a:srgbClr val="18212B"/>
                 </a:solidFill>
@@ -4915,8 +4915,8 @@
         </p:nvSpPr>
         <p:spPr>
           <a:xfrm>
-            <a:off x="7955279" y="2167128"/>
-            <a:ext cx="2606039" cy="146304"/>
+            <a:off x="8183879" y="2167128"/>
+            <a:ext cx="2240279" cy="146304"/>
           </a:xfrm>
           <a:prstGeom prst="rect">
             <a:avLst/>
@@ -4961,8 +4961,8 @@
         </p:nvSpPr>
         <p:spPr>
           <a:xfrm>
-            <a:off x="7955279" y="2167128"/>
-            <a:ext cx="1024173" cy="146304"/>
+            <a:off x="8183879" y="2167128"/>
+            <a:ext cx="880430" cy="146304"/>
           </a:xfrm>
           <a:prstGeom prst="rect">
             <a:avLst/>
@@ -5007,8 +5007,8 @@
         </p:nvSpPr>
         <p:spPr>
           <a:xfrm>
-            <a:off x="10652759" y="2139696"/>
-            <a:ext cx="548640" cy="201168"/>
+            <a:off x="10469880" y="2139696"/>
+            <a:ext cx="731520" cy="201168"/>
           </a:xfrm>
           <a:prstGeom prst="rect">
             <a:avLst/>
@@ -5043,7 +5043,7 @@
         <p:spPr>
           <a:xfrm>
             <a:off x="6382512" y="2532888"/>
-            <a:ext cx="1554480" cy="237744"/>
+            <a:ext cx="1828800" cy="237744"/>
           </a:xfrm>
           <a:prstGeom prst="rect">
             <a:avLst/>
@@ -5058,7 +5058,7 @@
           <a:p>
             <a:pPr algn="l"/>
             <a:r>
-              <a:rPr sz="900" b="1">
+              <a:rPr sz="850" b="1">
                 <a:solidFill>
                   <a:srgbClr val="18212B"/>
                 </a:solidFill>
@@ -5077,8 +5077,8 @@
         </p:nvSpPr>
         <p:spPr>
           <a:xfrm>
-            <a:off x="7955279" y="2551176"/>
-            <a:ext cx="2606039" cy="146304"/>
+            <a:off x="8183879" y="2551176"/>
+            <a:ext cx="2240279" cy="146304"/>
           </a:xfrm>
           <a:prstGeom prst="rect">
             <a:avLst/>
@@ -5123,8 +5123,8 @@
         </p:nvSpPr>
         <p:spPr>
           <a:xfrm>
-            <a:off x="7955279" y="2551176"/>
-            <a:ext cx="870417" cy="146304"/>
+            <a:off x="8183879" y="2551176"/>
+            <a:ext cx="748253" cy="146304"/>
           </a:xfrm>
           <a:prstGeom prst="rect">
             <a:avLst/>
@@ -5169,8 +5169,8 @@
         </p:nvSpPr>
         <p:spPr>
           <a:xfrm>
-            <a:off x="10652759" y="2523744"/>
-            <a:ext cx="548640" cy="201168"/>
+            <a:off x="10469880" y="2523744"/>
+            <a:ext cx="731520" cy="201168"/>
           </a:xfrm>
           <a:prstGeom prst="rect">
             <a:avLst/>
@@ -5259,7 +5259,7 @@
         <p:spPr>
           <a:xfrm>
             <a:off x="6382512" y="4050792"/>
-            <a:ext cx="1554480" cy="237744"/>
+            <a:ext cx="1828800" cy="237744"/>
           </a:xfrm>
           <a:prstGeom prst="rect">
             <a:avLst/>
@@ -5274,7 +5274,7 @@
           <a:p>
             <a:pPr algn="l"/>
             <a:r>
-              <a:rPr sz="900" b="1">
+              <a:rPr sz="850" b="1">
                 <a:solidFill>
                   <a:srgbClr val="18212B"/>
                 </a:solidFill>
@@ -5293,8 +5293,8 @@
         </p:nvSpPr>
         <p:spPr>
           <a:xfrm>
-            <a:off x="7955279" y="4069080"/>
-            <a:ext cx="2606039" cy="146304"/>
+            <a:off x="8183879" y="4069080"/>
+            <a:ext cx="2240279" cy="146304"/>
           </a:xfrm>
           <a:prstGeom prst="rect">
             <a:avLst/>
@@ -5339,8 +5339,8 @@
         </p:nvSpPr>
         <p:spPr>
           <a:xfrm>
-            <a:off x="7955279" y="4069080"/>
-            <a:ext cx="1402049" cy="146304"/>
+            <a:off x="8183879" y="4069080"/>
+            <a:ext cx="1205270" cy="146304"/>
           </a:xfrm>
           <a:prstGeom prst="rect">
             <a:avLst/>
@@ -5385,8 +5385,8 @@
         </p:nvSpPr>
         <p:spPr>
           <a:xfrm>
-            <a:off x="10652759" y="4041648"/>
-            <a:ext cx="548640" cy="201168"/>
+            <a:off x="10469880" y="4041648"/>
+            <a:ext cx="731520" cy="201168"/>
           </a:xfrm>
           <a:prstGeom prst="rect">
             <a:avLst/>
@@ -5421,7 +5421,7 @@
         <p:spPr>
           <a:xfrm>
             <a:off x="6382512" y="4434840"/>
-            <a:ext cx="1554480" cy="237744"/>
+            <a:ext cx="1828800" cy="237744"/>
           </a:xfrm>
           <a:prstGeom prst="rect">
             <a:avLst/>
@@ -5436,7 +5436,7 @@
           <a:p>
             <a:pPr algn="l"/>
             <a:r>
-              <a:rPr sz="900" b="1">
+              <a:rPr sz="850" b="1">
                 <a:solidFill>
                   <a:srgbClr val="18212B"/>
                 </a:solidFill>
@@ -5455,8 +5455,8 @@
         </p:nvSpPr>
         <p:spPr>
           <a:xfrm>
-            <a:off x="7955279" y="4453128"/>
-            <a:ext cx="2606039" cy="146304"/>
+            <a:off x="8183879" y="4453128"/>
+            <a:ext cx="2240279" cy="146304"/>
           </a:xfrm>
           <a:prstGeom prst="rect">
             <a:avLst/>
@@ -5501,8 +5501,8 @@
         </p:nvSpPr>
         <p:spPr>
           <a:xfrm>
-            <a:off x="7955279" y="4453128"/>
-            <a:ext cx="1329080" cy="146304"/>
+            <a:off x="8183879" y="4453128"/>
+            <a:ext cx="1142542" cy="146304"/>
           </a:xfrm>
           <a:prstGeom prst="rect">
             <a:avLst/>
@@ -5547,8 +5547,8 @@
         </p:nvSpPr>
         <p:spPr>
           <a:xfrm>
-            <a:off x="10652759" y="4425696"/>
-            <a:ext cx="548640" cy="201168"/>
+            <a:off x="10469880" y="4425696"/>
+            <a:ext cx="731520" cy="201168"/>
           </a:xfrm>
           <a:prstGeom prst="rect">
             <a:avLst/>
@@ -5583,7 +5583,7 @@
         <p:spPr>
           <a:xfrm>
             <a:off x="6382512" y="4818888"/>
-            <a:ext cx="1554480" cy="237744"/>
+            <a:ext cx="1828800" cy="237744"/>
           </a:xfrm>
           <a:prstGeom prst="rect">
             <a:avLst/>
@@ -5598,7 +5598,7 @@
           <a:p>
             <a:pPr algn="l"/>
             <a:r>
-              <a:rPr sz="900" b="1">
+              <a:rPr sz="850" b="1">
                 <a:solidFill>
                   <a:srgbClr val="18212B"/>
                 </a:solidFill>
@@ -5617,8 +5617,8 @@
         </p:nvSpPr>
         <p:spPr>
           <a:xfrm>
-            <a:off x="7955279" y="4837176"/>
-            <a:ext cx="2606039" cy="146304"/>
+            <a:off x="8183879" y="4837176"/>
+            <a:ext cx="2240279" cy="146304"/>
           </a:xfrm>
           <a:prstGeom prst="rect">
             <a:avLst/>
@@ -5663,8 +5663,8 @@
         </p:nvSpPr>
         <p:spPr>
           <a:xfrm>
-            <a:off x="7955279" y="4837176"/>
-            <a:ext cx="1545381" cy="146304"/>
+            <a:off x="8183879" y="4837176"/>
+            <a:ext cx="1328486" cy="146304"/>
           </a:xfrm>
           <a:prstGeom prst="rect">
             <a:avLst/>
@@ -5709,8 +5709,8 @@
         </p:nvSpPr>
         <p:spPr>
           <a:xfrm>
-            <a:off x="10652759" y="4809744"/>
-            <a:ext cx="548640" cy="201168"/>
+            <a:off x="10469880" y="4809744"/>
+            <a:ext cx="731520" cy="201168"/>
           </a:xfrm>
           <a:prstGeom prst="rect">
             <a:avLst/>
@@ -5745,7 +5745,7 @@
         <p:spPr>
           <a:xfrm>
             <a:off x="6382512" y="5202936"/>
-            <a:ext cx="1554480" cy="237744"/>
+            <a:ext cx="1828800" cy="237744"/>
           </a:xfrm>
           <a:prstGeom prst="rect">
             <a:avLst/>
@@ -5760,7 +5760,7 @@
           <a:p>
             <a:pPr algn="l"/>
             <a:r>
-              <a:rPr sz="900" b="1">
+              <a:rPr sz="850" b="1">
                 <a:solidFill>
                   <a:srgbClr val="18212B"/>
                 </a:solidFill>
@@ -5779,8 +5779,8 @@
         </p:nvSpPr>
         <p:spPr>
           <a:xfrm>
-            <a:off x="7955279" y="5221224"/>
-            <a:ext cx="2606039" cy="146304"/>
+            <a:off x="8183879" y="5221224"/>
+            <a:ext cx="2240279" cy="146304"/>
           </a:xfrm>
           <a:prstGeom prst="rect">
             <a:avLst/>
@@ -5825,8 +5825,8 @@
         </p:nvSpPr>
         <p:spPr>
           <a:xfrm>
-            <a:off x="7955279" y="5221224"/>
-            <a:ext cx="1980590" cy="146304"/>
+            <a:off x="8183879" y="5221224"/>
+            <a:ext cx="1702612" cy="146304"/>
           </a:xfrm>
           <a:prstGeom prst="rect">
             <a:avLst/>
@@ -5871,8 +5871,8 @@
         </p:nvSpPr>
         <p:spPr>
           <a:xfrm>
-            <a:off x="10652759" y="5193792"/>
-            <a:ext cx="548640" cy="201168"/>
+            <a:off x="10469880" y="5193792"/>
+            <a:ext cx="731520" cy="201168"/>
           </a:xfrm>
           <a:prstGeom prst="rect">
             <a:avLst/>
@@ -7706,7 +7706,7 @@
         <p:spPr>
           <a:xfrm>
             <a:off x="6382512" y="1764792"/>
-            <a:ext cx="1554480" cy="237744"/>
+            <a:ext cx="1828800" cy="237744"/>
           </a:xfrm>
           <a:prstGeom prst="rect">
             <a:avLst/>
@@ -7721,7 +7721,7 @@
           <a:p>
             <a:pPr algn="l"/>
             <a:r>
-              <a:rPr sz="900" b="1">
+              <a:rPr sz="850" b="1">
                 <a:solidFill>
                   <a:srgbClr val="18212B"/>
                 </a:solidFill>
@@ -7740,8 +7740,8 @@
         </p:nvSpPr>
         <p:spPr>
           <a:xfrm>
-            <a:off x="7955279" y="1783080"/>
-            <a:ext cx="2606039" cy="146304"/>
+            <a:off x="8183879" y="1783080"/>
+            <a:ext cx="2240279" cy="146304"/>
           </a:xfrm>
           <a:prstGeom prst="rect">
             <a:avLst/>
@@ -7786,7 +7786,7 @@
         </p:nvSpPr>
         <p:spPr>
           <a:xfrm>
-            <a:off x="7955279" y="1783080"/>
+            <a:off x="8183879" y="1783080"/>
             <a:ext cx="0" cy="146304"/>
           </a:xfrm>
           <a:prstGeom prst="rect">
@@ -7832,8 +7832,8 @@
         </p:nvSpPr>
         <p:spPr>
           <a:xfrm>
-            <a:off x="10652759" y="1755648"/>
-            <a:ext cx="548640" cy="201168"/>
+            <a:off x="10469880" y="1755648"/>
+            <a:ext cx="731520" cy="201168"/>
           </a:xfrm>
           <a:prstGeom prst="rect">
             <a:avLst/>
@@ -7868,7 +7868,7 @@
         <p:spPr>
           <a:xfrm>
             <a:off x="6382512" y="2148840"/>
-            <a:ext cx="1554480" cy="237744"/>
+            <a:ext cx="1828800" cy="237744"/>
           </a:xfrm>
           <a:prstGeom prst="rect">
             <a:avLst/>
@@ -7883,7 +7883,7 @@
           <a:p>
             <a:pPr algn="l"/>
             <a:r>
-              <a:rPr sz="900" b="1">
+              <a:rPr sz="850" b="1">
                 <a:solidFill>
                   <a:srgbClr val="18212B"/>
                 </a:solidFill>
@@ -7902,8 +7902,8 @@
         </p:nvSpPr>
         <p:spPr>
           <a:xfrm>
-            <a:off x="7955279" y="2167128"/>
-            <a:ext cx="2606039" cy="146304"/>
+            <a:off x="8183879" y="2167128"/>
+            <a:ext cx="2240279" cy="146304"/>
           </a:xfrm>
           <a:prstGeom prst="rect">
             <a:avLst/>
@@ -7948,8 +7948,8 @@
         </p:nvSpPr>
         <p:spPr>
           <a:xfrm>
-            <a:off x="7955279" y="2167128"/>
-            <a:ext cx="226725" cy="146304"/>
+            <a:off x="8183879" y="2167128"/>
+            <a:ext cx="194904" cy="146304"/>
           </a:xfrm>
           <a:prstGeom prst="rect">
             <a:avLst/>
@@ -7994,8 +7994,8 @@
         </p:nvSpPr>
         <p:spPr>
           <a:xfrm>
-            <a:off x="10652759" y="2139696"/>
-            <a:ext cx="548640" cy="201168"/>
+            <a:off x="10469880" y="2139696"/>
+            <a:ext cx="731520" cy="201168"/>
           </a:xfrm>
           <a:prstGeom prst="rect">
             <a:avLst/>
@@ -8030,7 +8030,7 @@
         <p:spPr>
           <a:xfrm>
             <a:off x="6382512" y="2532888"/>
-            <a:ext cx="1554480" cy="237744"/>
+            <a:ext cx="1828800" cy="237744"/>
           </a:xfrm>
           <a:prstGeom prst="rect">
             <a:avLst/>
@@ -8045,7 +8045,7 @@
           <a:p>
             <a:pPr algn="l"/>
             <a:r>
-              <a:rPr sz="900" b="1">
+              <a:rPr sz="850" b="1">
                 <a:solidFill>
                   <a:srgbClr val="18212B"/>
                 </a:solidFill>
@@ -8064,8 +8064,8 @@
         </p:nvSpPr>
         <p:spPr>
           <a:xfrm>
-            <a:off x="7955279" y="2551176"/>
-            <a:ext cx="2606039" cy="146304"/>
+            <a:off x="8183879" y="2551176"/>
+            <a:ext cx="2240279" cy="146304"/>
           </a:xfrm>
           <a:prstGeom prst="rect">
             <a:avLst/>
@@ -8110,8 +8110,8 @@
         </p:nvSpPr>
         <p:spPr>
           <a:xfrm>
-            <a:off x="7955279" y="2551176"/>
-            <a:ext cx="1230050" cy="146304"/>
+            <a:off x="8183879" y="2551176"/>
+            <a:ext cx="1057412" cy="146304"/>
           </a:xfrm>
           <a:prstGeom prst="rect">
             <a:avLst/>
@@ -8156,8 +8156,8 @@
         </p:nvSpPr>
         <p:spPr>
           <a:xfrm>
-            <a:off x="10652759" y="2523744"/>
-            <a:ext cx="548640" cy="201168"/>
+            <a:off x="10469880" y="2523744"/>
+            <a:ext cx="731520" cy="201168"/>
           </a:xfrm>
           <a:prstGeom prst="rect">
             <a:avLst/>
@@ -8192,7 +8192,7 @@
         <p:spPr>
           <a:xfrm>
             <a:off x="6382512" y="2916936"/>
-            <a:ext cx="1554480" cy="237744"/>
+            <a:ext cx="1828800" cy="237744"/>
           </a:xfrm>
           <a:prstGeom prst="rect">
             <a:avLst/>
@@ -8207,7 +8207,7 @@
           <a:p>
             <a:pPr algn="l"/>
             <a:r>
-              <a:rPr sz="900" b="1">
+              <a:rPr sz="850" b="1">
                 <a:solidFill>
                   <a:srgbClr val="18212B"/>
                 </a:solidFill>
@@ -8226,8 +8226,8 @@
         </p:nvSpPr>
         <p:spPr>
           <a:xfrm>
-            <a:off x="7955279" y="2935224"/>
-            <a:ext cx="2606039" cy="146304"/>
+            <a:off x="8183879" y="2935224"/>
+            <a:ext cx="2240279" cy="146304"/>
           </a:xfrm>
           <a:prstGeom prst="rect">
             <a:avLst/>
@@ -8272,8 +8272,8 @@
         </p:nvSpPr>
         <p:spPr>
           <a:xfrm>
-            <a:off x="7955279" y="2935224"/>
-            <a:ext cx="1886772" cy="146304"/>
+            <a:off x="8183879" y="2935224"/>
+            <a:ext cx="1621962" cy="146304"/>
           </a:xfrm>
           <a:prstGeom prst="rect">
             <a:avLst/>
@@ -8318,8 +8318,8 @@
         </p:nvSpPr>
         <p:spPr>
           <a:xfrm>
-            <a:off x="10652759" y="2907792"/>
-            <a:ext cx="548640" cy="201168"/>
+            <a:off x="10469880" y="2907792"/>
+            <a:ext cx="731520" cy="201168"/>
           </a:xfrm>
           <a:prstGeom prst="rect">
             <a:avLst/>
@@ -9674,7 +9674,7 @@
         <p:spPr>
           <a:xfrm>
             <a:off x="6382512" y="1764792"/>
-            <a:ext cx="1554480" cy="237744"/>
+            <a:ext cx="1828800" cy="237744"/>
           </a:xfrm>
           <a:prstGeom prst="rect">
             <a:avLst/>
@@ -9689,7 +9689,7 @@
           <a:p>
             <a:pPr algn="l"/>
             <a:r>
-              <a:rPr sz="900" b="1">
+              <a:rPr sz="850" b="1">
                 <a:solidFill>
                   <a:srgbClr val="18212B"/>
                 </a:solidFill>
@@ -9708,8 +9708,8 @@
         </p:nvSpPr>
         <p:spPr>
           <a:xfrm>
-            <a:off x="7955279" y="1783080"/>
-            <a:ext cx="2606039" cy="146304"/>
+            <a:off x="8183879" y="1783080"/>
+            <a:ext cx="2240279" cy="146304"/>
           </a:xfrm>
           <a:prstGeom prst="rect">
             <a:avLst/>
@@ -9754,8 +9754,8 @@
         </p:nvSpPr>
         <p:spPr>
           <a:xfrm>
-            <a:off x="7955279" y="1783080"/>
-            <a:ext cx="2520040" cy="146304"/>
+            <a:off x="8183879" y="1783080"/>
+            <a:ext cx="2166350" cy="146304"/>
           </a:xfrm>
           <a:prstGeom prst="rect">
             <a:avLst/>
@@ -9800,8 +9800,8 @@
         </p:nvSpPr>
         <p:spPr>
           <a:xfrm>
-            <a:off x="10652759" y="1755648"/>
-            <a:ext cx="548640" cy="201168"/>
+            <a:off x="10469880" y="1755648"/>
+            <a:ext cx="731520" cy="201168"/>
           </a:xfrm>
           <a:prstGeom prst="rect">
             <a:avLst/>
@@ -9836,7 +9836,7 @@
         <p:spPr>
           <a:xfrm>
             <a:off x="6382512" y="2148840"/>
-            <a:ext cx="1554480" cy="237744"/>
+            <a:ext cx="1828800" cy="237744"/>
           </a:xfrm>
           <a:prstGeom prst="rect">
             <a:avLst/>
@@ -9851,7 +9851,7 @@
           <a:p>
             <a:pPr algn="l"/>
             <a:r>
-              <a:rPr sz="900" b="1">
+              <a:rPr sz="850" b="1">
                 <a:solidFill>
                   <a:srgbClr val="18212B"/>
                 </a:solidFill>
@@ -9870,8 +9870,8 @@
         </p:nvSpPr>
         <p:spPr>
           <a:xfrm>
-            <a:off x="7955279" y="2167128"/>
-            <a:ext cx="2606039" cy="146304"/>
+            <a:off x="8183879" y="2167128"/>
+            <a:ext cx="2240279" cy="146304"/>
           </a:xfrm>
           <a:prstGeom prst="rect">
             <a:avLst/>
@@ -9916,8 +9916,8 @@
         </p:nvSpPr>
         <p:spPr>
           <a:xfrm>
-            <a:off x="7955279" y="2167128"/>
-            <a:ext cx="2520040" cy="146304"/>
+            <a:off x="8183879" y="2167128"/>
+            <a:ext cx="2166350" cy="146304"/>
           </a:xfrm>
           <a:prstGeom prst="rect">
             <a:avLst/>
@@ -9962,8 +9962,8 @@
         </p:nvSpPr>
         <p:spPr>
           <a:xfrm>
-            <a:off x="10652759" y="2139696"/>
-            <a:ext cx="548640" cy="201168"/>
+            <a:off x="10469880" y="2139696"/>
+            <a:ext cx="731520" cy="201168"/>
           </a:xfrm>
           <a:prstGeom prst="rect">
             <a:avLst/>
@@ -9998,7 +9998,7 @@
         <p:spPr>
           <a:xfrm>
             <a:off x="6382512" y="2532888"/>
-            <a:ext cx="1554480" cy="237744"/>
+            <a:ext cx="1828800" cy="237744"/>
           </a:xfrm>
           <a:prstGeom prst="rect">
             <a:avLst/>
@@ -10013,7 +10013,7 @@
           <a:p>
             <a:pPr algn="l"/>
             <a:r>
-              <a:rPr sz="900" b="1">
+              <a:rPr sz="850" b="1">
                 <a:solidFill>
                   <a:srgbClr val="18212B"/>
                 </a:solidFill>
@@ -10032,8 +10032,8 @@
         </p:nvSpPr>
         <p:spPr>
           <a:xfrm>
-            <a:off x="7955279" y="2551176"/>
-            <a:ext cx="2606039" cy="146304"/>
+            <a:off x="8183879" y="2551176"/>
+            <a:ext cx="2240279" cy="146304"/>
           </a:xfrm>
           <a:prstGeom prst="rect">
             <a:avLst/>
@@ -10078,8 +10078,8 @@
         </p:nvSpPr>
         <p:spPr>
           <a:xfrm>
-            <a:off x="7955279" y="2551176"/>
-            <a:ext cx="85999" cy="146304"/>
+            <a:off x="8183879" y="2551176"/>
+            <a:ext cx="73929" cy="146304"/>
           </a:xfrm>
           <a:prstGeom prst="rect">
             <a:avLst/>
@@ -10124,8 +10124,8 @@
         </p:nvSpPr>
         <p:spPr>
           <a:xfrm>
-            <a:off x="10652759" y="2523744"/>
-            <a:ext cx="548640" cy="201168"/>
+            <a:off x="10469880" y="2523744"/>
+            <a:ext cx="731520" cy="201168"/>
           </a:xfrm>
           <a:prstGeom prst="rect">
             <a:avLst/>
@@ -10160,7 +10160,7 @@
         <p:spPr>
           <a:xfrm>
             <a:off x="6382512" y="2916936"/>
-            <a:ext cx="1554480" cy="237744"/>
+            <a:ext cx="1828800" cy="237744"/>
           </a:xfrm>
           <a:prstGeom prst="rect">
             <a:avLst/>
@@ -10175,7 +10175,7 @@
           <a:p>
             <a:pPr algn="l"/>
             <a:r>
-              <a:rPr sz="900" b="1">
+              <a:rPr sz="850" b="1">
                 <a:solidFill>
                   <a:srgbClr val="18212B"/>
                 </a:solidFill>
@@ -10194,8 +10194,8 @@
         </p:nvSpPr>
         <p:spPr>
           <a:xfrm>
-            <a:off x="7955279" y="2935224"/>
-            <a:ext cx="2606039" cy="146304"/>
+            <a:off x="8183879" y="2935224"/>
+            <a:ext cx="2240279" cy="146304"/>
           </a:xfrm>
           <a:prstGeom prst="rect">
             <a:avLst/>
@@ -10240,8 +10240,8 @@
         </p:nvSpPr>
         <p:spPr>
           <a:xfrm>
-            <a:off x="7955279" y="2935224"/>
-            <a:ext cx="2194285" cy="146304"/>
+            <a:off x="8183879" y="2935224"/>
+            <a:ext cx="1886315" cy="146304"/>
           </a:xfrm>
           <a:prstGeom prst="rect">
             <a:avLst/>
@@ -10286,8 +10286,8 @@
         </p:nvSpPr>
         <p:spPr>
           <a:xfrm>
-            <a:off x="10652759" y="2907792"/>
-            <a:ext cx="548640" cy="201168"/>
+            <a:off x="10469880" y="2907792"/>
+            <a:ext cx="731520" cy="201168"/>
           </a:xfrm>
           <a:prstGeom prst="rect">
             <a:avLst/>
@@ -11610,7 +11610,7 @@
         <p:spPr>
           <a:xfrm>
             <a:off x="6382512" y="1764792"/>
-            <a:ext cx="1554480" cy="237744"/>
+            <a:ext cx="1828800" cy="237744"/>
           </a:xfrm>
           <a:prstGeom prst="rect">
             <a:avLst/>
@@ -11625,7 +11625,7 @@
           <a:p>
             <a:pPr algn="l"/>
             <a:r>
-              <a:rPr sz="900" b="1">
+              <a:rPr sz="850" b="1">
                 <a:solidFill>
                   <a:srgbClr val="18212B"/>
                 </a:solidFill>
@@ -11644,8 +11644,8 @@
         </p:nvSpPr>
         <p:spPr>
           <a:xfrm>
-            <a:off x="7955279" y="1783080"/>
-            <a:ext cx="2606039" cy="146304"/>
+            <a:off x="8183879" y="1783080"/>
+            <a:ext cx="2240279" cy="146304"/>
           </a:xfrm>
           <a:prstGeom prst="rect">
             <a:avLst/>
@@ -11690,8 +11690,8 @@
         </p:nvSpPr>
         <p:spPr>
           <a:xfrm>
-            <a:off x="7955279" y="1783080"/>
-            <a:ext cx="1073688" cy="146304"/>
+            <a:off x="8183879" y="1783080"/>
+            <a:ext cx="922995" cy="146304"/>
           </a:xfrm>
           <a:prstGeom prst="rect">
             <a:avLst/>
@@ -11736,8 +11736,8 @@
         </p:nvSpPr>
         <p:spPr>
           <a:xfrm>
-            <a:off x="10652759" y="1755648"/>
-            <a:ext cx="548640" cy="201168"/>
+            <a:off x="10469880" y="1755648"/>
+            <a:ext cx="731520" cy="201168"/>
           </a:xfrm>
           <a:prstGeom prst="rect">
             <a:avLst/>
@@ -11772,7 +11772,7 @@
         <p:spPr>
           <a:xfrm>
             <a:off x="6382512" y="2148840"/>
-            <a:ext cx="1554480" cy="237744"/>
+            <a:ext cx="1828800" cy="237744"/>
           </a:xfrm>
           <a:prstGeom prst="rect">
             <a:avLst/>
@@ -11787,7 +11787,7 @@
           <a:p>
             <a:pPr algn="l"/>
             <a:r>
-              <a:rPr sz="900" b="1">
+              <a:rPr sz="850" b="1">
                 <a:solidFill>
                   <a:srgbClr val="18212B"/>
                 </a:solidFill>
@@ -11806,8 +11806,8 @@
         </p:nvSpPr>
         <p:spPr>
           <a:xfrm>
-            <a:off x="7955279" y="2167128"/>
-            <a:ext cx="2606039" cy="146304"/>
+            <a:off x="8183879" y="2167128"/>
+            <a:ext cx="2240279" cy="146304"/>
           </a:xfrm>
           <a:prstGeom prst="rect">
             <a:avLst/>
@@ -11852,8 +11852,8 @@
         </p:nvSpPr>
         <p:spPr>
           <a:xfrm>
-            <a:off x="7955279" y="2167128"/>
-            <a:ext cx="956416" cy="146304"/>
+            <a:off x="8183879" y="2167128"/>
+            <a:ext cx="822182" cy="146304"/>
           </a:xfrm>
           <a:prstGeom prst="rect">
             <a:avLst/>
@@ -11898,8 +11898,8 @@
         </p:nvSpPr>
         <p:spPr>
           <a:xfrm>
-            <a:off x="10652759" y="2139696"/>
-            <a:ext cx="548640" cy="201168"/>
+            <a:off x="10469880" y="2139696"/>
+            <a:ext cx="731520" cy="201168"/>
           </a:xfrm>
           <a:prstGeom prst="rect">
             <a:avLst/>
@@ -11934,7 +11934,7 @@
         <p:spPr>
           <a:xfrm>
             <a:off x="6382512" y="2532888"/>
-            <a:ext cx="1554480" cy="237744"/>
+            <a:ext cx="1828800" cy="237744"/>
           </a:xfrm>
           <a:prstGeom prst="rect">
             <a:avLst/>
@@ -11949,7 +11949,7 @@
           <a:p>
             <a:pPr algn="l"/>
             <a:r>
-              <a:rPr sz="900" b="1">
+              <a:rPr sz="850" b="1">
                 <a:solidFill>
                   <a:srgbClr val="18212B"/>
                 </a:solidFill>
@@ -11968,8 +11968,8 @@
         </p:nvSpPr>
         <p:spPr>
           <a:xfrm>
-            <a:off x="7955279" y="2551176"/>
-            <a:ext cx="2606039" cy="146304"/>
+            <a:off x="8183879" y="2551176"/>
+            <a:ext cx="2240279" cy="146304"/>
           </a:xfrm>
           <a:prstGeom prst="rect">
             <a:avLst/>
@@ -12014,8 +12014,8 @@
         </p:nvSpPr>
         <p:spPr>
           <a:xfrm>
-            <a:off x="7955279" y="2551176"/>
-            <a:ext cx="565510" cy="146304"/>
+            <a:off x="8183879" y="2551176"/>
+            <a:ext cx="486140" cy="146304"/>
           </a:xfrm>
           <a:prstGeom prst="rect">
             <a:avLst/>
@@ -12060,8 +12060,8 @@
         </p:nvSpPr>
         <p:spPr>
           <a:xfrm>
-            <a:off x="10652759" y="2523744"/>
-            <a:ext cx="548640" cy="201168"/>
+            <a:off x="10469880" y="2523744"/>
+            <a:ext cx="731520" cy="201168"/>
           </a:xfrm>
           <a:prstGeom prst="rect">
             <a:avLst/>
@@ -12096,7 +12096,7 @@
         <p:spPr>
           <a:xfrm>
             <a:off x="6382512" y="2916936"/>
-            <a:ext cx="1554480" cy="237744"/>
+            <a:ext cx="1828800" cy="237744"/>
           </a:xfrm>
           <a:prstGeom prst="rect">
             <a:avLst/>
@@ -12111,7 +12111,7 @@
           <a:p>
             <a:pPr algn="l"/>
             <a:r>
-              <a:rPr sz="900" b="1">
+              <a:rPr sz="850" b="1">
                 <a:solidFill>
                   <a:srgbClr val="18212B"/>
                 </a:solidFill>
@@ -12130,8 +12130,8 @@
         </p:nvSpPr>
         <p:spPr>
           <a:xfrm>
-            <a:off x="7955279" y="2935224"/>
-            <a:ext cx="2606039" cy="146304"/>
+            <a:off x="8183879" y="2935224"/>
+            <a:ext cx="2240279" cy="146304"/>
           </a:xfrm>
           <a:prstGeom prst="rect">
             <a:avLst/>
@@ -12176,8 +12176,8 @@
         </p:nvSpPr>
         <p:spPr>
           <a:xfrm>
-            <a:off x="7955279" y="2935224"/>
-            <a:ext cx="2063983" cy="146304"/>
+            <a:off x="8183879" y="2935224"/>
+            <a:ext cx="1774301" cy="146304"/>
           </a:xfrm>
           <a:prstGeom prst="rect">
             <a:avLst/>
@@ -12222,8 +12222,8 @@
         </p:nvSpPr>
         <p:spPr>
           <a:xfrm>
-            <a:off x="10652759" y="2907792"/>
-            <a:ext cx="548640" cy="201168"/>
+            <a:off x="10469880" y="2907792"/>
+            <a:ext cx="731520" cy="201168"/>
           </a:xfrm>
           <a:prstGeom prst="rect">
             <a:avLst/>
@@ -12312,7 +12312,7 @@
         <p:spPr>
           <a:xfrm>
             <a:off x="6382512" y="4187952"/>
-            <a:ext cx="1554480" cy="237744"/>
+            <a:ext cx="1828800" cy="237744"/>
           </a:xfrm>
           <a:prstGeom prst="rect">
             <a:avLst/>
@@ -12327,7 +12327,7 @@
           <a:p>
             <a:pPr algn="l"/>
             <a:r>
-              <a:rPr sz="900" b="1">
+              <a:rPr sz="850" b="1">
                 <a:solidFill>
                   <a:srgbClr val="18212B"/>
                 </a:solidFill>
@@ -12346,8 +12346,8 @@
         </p:nvSpPr>
         <p:spPr>
           <a:xfrm>
-            <a:off x="7955279" y="4206240"/>
-            <a:ext cx="2606039" cy="146304"/>
+            <a:off x="8183879" y="4206240"/>
+            <a:ext cx="2240279" cy="146304"/>
           </a:xfrm>
           <a:prstGeom prst="rect">
             <a:avLst/>
@@ -12392,8 +12392,8 @@
         </p:nvSpPr>
         <p:spPr>
           <a:xfrm>
-            <a:off x="7955279" y="4206240"/>
-            <a:ext cx="682782" cy="146304"/>
+            <a:off x="8183879" y="4206240"/>
+            <a:ext cx="586953" cy="146304"/>
           </a:xfrm>
           <a:prstGeom prst="rect">
             <a:avLst/>
@@ -12438,8 +12438,8 @@
         </p:nvSpPr>
         <p:spPr>
           <a:xfrm>
-            <a:off x="10652759" y="4178807"/>
-            <a:ext cx="548640" cy="201168"/>
+            <a:off x="10469880" y="4178807"/>
+            <a:ext cx="731520" cy="201168"/>
           </a:xfrm>
           <a:prstGeom prst="rect">
             <a:avLst/>
@@ -12474,7 +12474,7 @@
         <p:spPr>
           <a:xfrm>
             <a:off x="6382512" y="4572000"/>
-            <a:ext cx="1554480" cy="237744"/>
+            <a:ext cx="1828800" cy="237744"/>
           </a:xfrm>
           <a:prstGeom prst="rect">
             <a:avLst/>
@@ -12489,7 +12489,7 @@
           <a:p>
             <a:pPr algn="l"/>
             <a:r>
-              <a:rPr sz="900" b="1">
+              <a:rPr sz="850" b="1">
                 <a:solidFill>
                   <a:srgbClr val="18212B"/>
                 </a:solidFill>
@@ -12508,8 +12508,8 @@
         </p:nvSpPr>
         <p:spPr>
           <a:xfrm>
-            <a:off x="7955279" y="4590288"/>
-            <a:ext cx="2606039" cy="146304"/>
+            <a:off x="8183879" y="4590288"/>
+            <a:ext cx="2240279" cy="146304"/>
           </a:xfrm>
           <a:prstGeom prst="rect">
             <a:avLst/>
@@ -12554,8 +12554,8 @@
         </p:nvSpPr>
         <p:spPr>
           <a:xfrm>
-            <a:off x="7955279" y="4590288"/>
-            <a:ext cx="2019680" cy="146304"/>
+            <a:off x="8183879" y="4590288"/>
+            <a:ext cx="1736216" cy="146304"/>
           </a:xfrm>
           <a:prstGeom prst="rect">
             <a:avLst/>
@@ -12600,8 +12600,8 @@
         </p:nvSpPr>
         <p:spPr>
           <a:xfrm>
-            <a:off x="10652759" y="4562855"/>
-            <a:ext cx="548640" cy="201168"/>
+            <a:off x="10469880" y="4562855"/>
+            <a:ext cx="731520" cy="201168"/>
           </a:xfrm>
           <a:prstGeom prst="rect">
             <a:avLst/>
@@ -12636,7 +12636,7 @@
         <p:spPr>
           <a:xfrm>
             <a:off x="6382512" y="4956048"/>
-            <a:ext cx="1554480" cy="237744"/>
+            <a:ext cx="1828800" cy="237744"/>
           </a:xfrm>
           <a:prstGeom prst="rect">
             <a:avLst/>
@@ -12651,7 +12651,7 @@
           <a:p>
             <a:pPr algn="l"/>
             <a:r>
-              <a:rPr sz="900" b="1">
+              <a:rPr sz="850" b="1">
                 <a:solidFill>
                   <a:srgbClr val="18212B"/>
                 </a:solidFill>
@@ -12670,8 +12670,8 @@
         </p:nvSpPr>
         <p:spPr>
           <a:xfrm>
-            <a:off x="7955279" y="4974336"/>
-            <a:ext cx="2606039" cy="146304"/>
+            <a:off x="8183879" y="4974336"/>
+            <a:ext cx="2240279" cy="146304"/>
           </a:xfrm>
           <a:prstGeom prst="rect">
             <a:avLst/>
@@ -12716,8 +12716,8 @@
         </p:nvSpPr>
         <p:spPr>
           <a:xfrm>
-            <a:off x="7955279" y="4974336"/>
-            <a:ext cx="2123922" cy="146304"/>
+            <a:off x="8183879" y="4974336"/>
+            <a:ext cx="1825828" cy="146304"/>
           </a:xfrm>
           <a:prstGeom prst="rect">
             <a:avLst/>
@@ -12762,8 +12762,8 @@
         </p:nvSpPr>
         <p:spPr>
           <a:xfrm>
-            <a:off x="10652759" y="4946903"/>
-            <a:ext cx="548640" cy="201168"/>
+            <a:off x="10469880" y="4946903"/>
+            <a:ext cx="731520" cy="201168"/>
           </a:xfrm>
           <a:prstGeom prst="rect">
             <a:avLst/>
@@ -15787,7 +15787,7 @@
         <p:spPr>
           <a:xfrm>
             <a:off x="6382512" y="1764792"/>
-            <a:ext cx="1554480" cy="237744"/>
+            <a:ext cx="1828800" cy="237744"/>
           </a:xfrm>
           <a:prstGeom prst="rect">
             <a:avLst/>
@@ -15802,7 +15802,7 @@
           <a:p>
             <a:pPr algn="l"/>
             <a:r>
-              <a:rPr sz="900" b="1">
+              <a:rPr sz="850" b="1">
                 <a:solidFill>
                   <a:srgbClr val="18212B"/>
                 </a:solidFill>
@@ -15821,8 +15821,8 @@
         </p:nvSpPr>
         <p:spPr>
           <a:xfrm>
-            <a:off x="7955279" y="1783080"/>
-            <a:ext cx="2606039" cy="146304"/>
+            <a:off x="8183879" y="1783080"/>
+            <a:ext cx="2240279" cy="146304"/>
           </a:xfrm>
           <a:prstGeom prst="rect">
             <a:avLst/>
@@ -15867,8 +15867,8 @@
         </p:nvSpPr>
         <p:spPr>
           <a:xfrm>
-            <a:off x="7955279" y="1783080"/>
-            <a:ext cx="1172717" cy="146304"/>
+            <a:off x="8183879" y="1783080"/>
+            <a:ext cx="1008125" cy="146304"/>
           </a:xfrm>
           <a:prstGeom prst="rect">
             <a:avLst/>
@@ -15913,8 +15913,8 @@
         </p:nvSpPr>
         <p:spPr>
           <a:xfrm>
-            <a:off x="10652759" y="1755648"/>
-            <a:ext cx="548640" cy="201168"/>
+            <a:off x="10469880" y="1755648"/>
+            <a:ext cx="731520" cy="201168"/>
           </a:xfrm>
           <a:prstGeom prst="rect">
             <a:avLst/>
@@ -15949,7 +15949,7 @@
         <p:spPr>
           <a:xfrm>
             <a:off x="6382512" y="2148840"/>
-            <a:ext cx="1554480" cy="237744"/>
+            <a:ext cx="1828800" cy="237744"/>
           </a:xfrm>
           <a:prstGeom prst="rect">
             <a:avLst/>
@@ -15964,7 +15964,7 @@
           <a:p>
             <a:pPr algn="l"/>
             <a:r>
-              <a:rPr sz="900" b="1">
+              <a:rPr sz="850" b="1">
                 <a:solidFill>
                   <a:srgbClr val="18212B"/>
                 </a:solidFill>
@@ -15983,8 +15983,8 @@
         </p:nvSpPr>
         <p:spPr>
           <a:xfrm>
-            <a:off x="7955279" y="2167128"/>
-            <a:ext cx="2606039" cy="146304"/>
+            <a:off x="8183879" y="2167128"/>
+            <a:ext cx="2240279" cy="146304"/>
           </a:xfrm>
           <a:prstGeom prst="rect">
             <a:avLst/>
@@ -16029,8 +16029,8 @@
         </p:nvSpPr>
         <p:spPr>
           <a:xfrm>
-            <a:off x="7955279" y="2167128"/>
-            <a:ext cx="781811" cy="146304"/>
+            <a:off x="8183879" y="2167128"/>
+            <a:ext cx="672083" cy="146304"/>
           </a:xfrm>
           <a:prstGeom prst="rect">
             <a:avLst/>
@@ -16075,8 +16075,8 @@
         </p:nvSpPr>
         <p:spPr>
           <a:xfrm>
-            <a:off x="10652759" y="2139696"/>
-            <a:ext cx="548640" cy="201168"/>
+            <a:off x="10469880" y="2139696"/>
+            <a:ext cx="731520" cy="201168"/>
           </a:xfrm>
           <a:prstGeom prst="rect">
             <a:avLst/>
@@ -16111,7 +16111,7 @@
         <p:spPr>
           <a:xfrm>
             <a:off x="6382512" y="2532888"/>
-            <a:ext cx="1554480" cy="237744"/>
+            <a:ext cx="1828800" cy="237744"/>
           </a:xfrm>
           <a:prstGeom prst="rect">
             <a:avLst/>
@@ -16126,7 +16126,7 @@
           <a:p>
             <a:pPr algn="l"/>
             <a:r>
-              <a:rPr sz="900" b="1">
+              <a:rPr sz="850" b="1">
                 <a:solidFill>
                   <a:srgbClr val="18212B"/>
                 </a:solidFill>
@@ -16145,8 +16145,8 @@
         </p:nvSpPr>
         <p:spPr>
           <a:xfrm>
-            <a:off x="7955279" y="2551176"/>
-            <a:ext cx="2606039" cy="146304"/>
+            <a:off x="8183879" y="2551176"/>
+            <a:ext cx="2240279" cy="146304"/>
           </a:xfrm>
           <a:prstGeom prst="rect">
             <a:avLst/>
@@ -16191,8 +16191,8 @@
         </p:nvSpPr>
         <p:spPr>
           <a:xfrm>
-            <a:off x="7955279" y="2551176"/>
-            <a:ext cx="1798167" cy="146304"/>
+            <a:off x="8183879" y="2551176"/>
+            <a:ext cx="1545793" cy="146304"/>
           </a:xfrm>
           <a:prstGeom prst="rect">
             <a:avLst/>
@@ -16237,8 +16237,8 @@
         </p:nvSpPr>
         <p:spPr>
           <a:xfrm>
-            <a:off x="10652759" y="2523744"/>
-            <a:ext cx="548640" cy="201168"/>
+            <a:off x="10469880" y="2523744"/>
+            <a:ext cx="731520" cy="201168"/>
           </a:xfrm>
           <a:prstGeom prst="rect">
             <a:avLst/>
@@ -16327,7 +16327,7 @@
         <p:spPr>
           <a:xfrm>
             <a:off x="6382512" y="4050792"/>
-            <a:ext cx="1554480" cy="237744"/>
+            <a:ext cx="1828800" cy="237744"/>
           </a:xfrm>
           <a:prstGeom prst="rect">
             <a:avLst/>
@@ -16342,7 +16342,7 @@
           <a:p>
             <a:pPr algn="l"/>
             <a:r>
-              <a:rPr sz="900" b="1">
+              <a:rPr sz="850" b="1">
                 <a:solidFill>
                   <a:srgbClr val="18212B"/>
                 </a:solidFill>
@@ -16361,8 +16361,8 @@
         </p:nvSpPr>
         <p:spPr>
           <a:xfrm>
-            <a:off x="7955279" y="4069080"/>
-            <a:ext cx="2606039" cy="146304"/>
+            <a:off x="8183879" y="4069080"/>
+            <a:ext cx="2240279" cy="146304"/>
           </a:xfrm>
           <a:prstGeom prst="rect">
             <a:avLst/>
@@ -16407,8 +16407,8 @@
         </p:nvSpPr>
         <p:spPr>
           <a:xfrm>
-            <a:off x="7955279" y="4069080"/>
-            <a:ext cx="677570" cy="146304"/>
+            <a:off x="8183879" y="4069080"/>
+            <a:ext cx="582472" cy="146304"/>
           </a:xfrm>
           <a:prstGeom prst="rect">
             <a:avLst/>
@@ -16453,8 +16453,8 @@
         </p:nvSpPr>
         <p:spPr>
           <a:xfrm>
-            <a:off x="10652759" y="4041648"/>
-            <a:ext cx="548640" cy="201168"/>
+            <a:off x="10469880" y="4041648"/>
+            <a:ext cx="731520" cy="201168"/>
           </a:xfrm>
           <a:prstGeom prst="rect">
             <a:avLst/>
@@ -16489,7 +16489,7 @@
         <p:spPr>
           <a:xfrm>
             <a:off x="6382512" y="4434840"/>
-            <a:ext cx="1554480" cy="237744"/>
+            <a:ext cx="1828800" cy="237744"/>
           </a:xfrm>
           <a:prstGeom prst="rect">
             <a:avLst/>
@@ -16504,7 +16504,7 @@
           <a:p>
             <a:pPr algn="l"/>
             <a:r>
-              <a:rPr sz="900" b="1">
+              <a:rPr sz="850" b="1">
                 <a:solidFill>
                   <a:srgbClr val="18212B"/>
                 </a:solidFill>
@@ -16523,8 +16523,8 @@
         </p:nvSpPr>
         <p:spPr>
           <a:xfrm>
-            <a:off x="7955279" y="4453128"/>
-            <a:ext cx="2606039" cy="146304"/>
+            <a:off x="8183879" y="4453128"/>
+            <a:ext cx="2240279" cy="146304"/>
           </a:xfrm>
           <a:prstGeom prst="rect">
             <a:avLst/>
@@ -16569,8 +16569,8 @@
         </p:nvSpPr>
         <p:spPr>
           <a:xfrm>
-            <a:off x="7955279" y="4453128"/>
-            <a:ext cx="1485442" cy="146304"/>
+            <a:off x="8183879" y="4453128"/>
+            <a:ext cx="1276959" cy="146304"/>
           </a:xfrm>
           <a:prstGeom prst="rect">
             <a:avLst/>
@@ -16615,8 +16615,8 @@
         </p:nvSpPr>
         <p:spPr>
           <a:xfrm>
-            <a:off x="10652759" y="4425696"/>
-            <a:ext cx="548640" cy="201168"/>
+            <a:off x="10469880" y="4425696"/>
+            <a:ext cx="731520" cy="201168"/>
           </a:xfrm>
           <a:prstGeom prst="rect">
             <a:avLst/>
@@ -16651,7 +16651,7 @@
         <p:spPr>
           <a:xfrm>
             <a:off x="6382512" y="4818888"/>
-            <a:ext cx="1554480" cy="237744"/>
+            <a:ext cx="1828800" cy="237744"/>
           </a:xfrm>
           <a:prstGeom prst="rect">
             <a:avLst/>
@@ -16666,7 +16666,7 @@
           <a:p>
             <a:pPr algn="l"/>
             <a:r>
-              <a:rPr sz="900" b="1">
+              <a:rPr sz="850" b="1">
                 <a:solidFill>
                   <a:srgbClr val="18212B"/>
                 </a:solidFill>
@@ -16685,8 +16685,8 @@
         </p:nvSpPr>
         <p:spPr>
           <a:xfrm>
-            <a:off x="7955279" y="4837176"/>
-            <a:ext cx="2606039" cy="146304"/>
+            <a:off x="8183879" y="4837176"/>
+            <a:ext cx="2240279" cy="146304"/>
           </a:xfrm>
           <a:prstGeom prst="rect">
             <a:avLst/>
@@ -16731,8 +16731,8 @@
         </p:nvSpPr>
         <p:spPr>
           <a:xfrm>
-            <a:off x="7955279" y="4837176"/>
-            <a:ext cx="1850288" cy="146304"/>
+            <a:off x="8183879" y="4837176"/>
+            <a:ext cx="1590598" cy="146304"/>
           </a:xfrm>
           <a:prstGeom prst="rect">
             <a:avLst/>
@@ -16777,8 +16777,8 @@
         </p:nvSpPr>
         <p:spPr>
           <a:xfrm>
-            <a:off x="10652759" y="4809744"/>
-            <a:ext cx="548640" cy="201168"/>
+            <a:off x="10469880" y="4809744"/>
+            <a:ext cx="731520" cy="201168"/>
           </a:xfrm>
           <a:prstGeom prst="rect">
             <a:avLst/>
@@ -17002,7 +17002,7 @@
         <p:spPr>
           <a:xfrm>
             <a:off x="713232" y="1901952"/>
-            <a:ext cx="1554480" cy="237744"/>
+            <a:ext cx="1828800" cy="237744"/>
           </a:xfrm>
           <a:prstGeom prst="rect">
             <a:avLst/>
@@ -17017,7 +17017,7 @@
           <a:p>
             <a:pPr algn="l"/>
             <a:r>
-              <a:rPr sz="900" b="1">
+              <a:rPr sz="850" b="1">
                 <a:solidFill>
                   <a:srgbClr val="18212B"/>
                 </a:solidFill>
@@ -17036,8 +17036,8 @@
         </p:nvSpPr>
         <p:spPr>
           <a:xfrm>
-            <a:off x="2286000" y="1920240"/>
-            <a:ext cx="2788920" cy="146304"/>
+            <a:off x="2514600" y="1920240"/>
+            <a:ext cx="2423160" cy="146304"/>
           </a:xfrm>
           <a:prstGeom prst="rect">
             <a:avLst/>
@@ -17082,8 +17082,8 @@
         </p:nvSpPr>
         <p:spPr>
           <a:xfrm>
-            <a:off x="2286000" y="1920240"/>
-            <a:ext cx="725119" cy="146304"/>
+            <a:off x="2514600" y="1920240"/>
+            <a:ext cx="630021" cy="146304"/>
           </a:xfrm>
           <a:prstGeom prst="rect">
             <a:avLst/>
@@ -17128,8 +17128,8 @@
         </p:nvSpPr>
         <p:spPr>
           <a:xfrm>
-            <a:off x="5166359" y="1892808"/>
-            <a:ext cx="548640" cy="201168"/>
+            <a:off x="4983479" y="1892808"/>
+            <a:ext cx="731520" cy="201168"/>
           </a:xfrm>
           <a:prstGeom prst="rect">
             <a:avLst/>
@@ -17164,7 +17164,7 @@
         <p:spPr>
           <a:xfrm>
             <a:off x="713232" y="2286000"/>
-            <a:ext cx="1554480" cy="237744"/>
+            <a:ext cx="1828800" cy="237744"/>
           </a:xfrm>
           <a:prstGeom prst="rect">
             <a:avLst/>
@@ -17179,7 +17179,7 @@
           <a:p>
             <a:pPr algn="l"/>
             <a:r>
-              <a:rPr sz="900" b="1">
+              <a:rPr sz="850" b="1">
                 <a:solidFill>
                   <a:srgbClr val="18212B"/>
                 </a:solidFill>
@@ -17198,8 +17198,8 @@
         </p:nvSpPr>
         <p:spPr>
           <a:xfrm>
-            <a:off x="2286000" y="2304288"/>
-            <a:ext cx="2788920" cy="146304"/>
+            <a:off x="2514600" y="2304288"/>
+            <a:ext cx="2423160" cy="146304"/>
           </a:xfrm>
           <a:prstGeom prst="rect">
             <a:avLst/>
@@ -17244,8 +17244,8 @@
         </p:nvSpPr>
         <p:spPr>
           <a:xfrm>
-            <a:off x="2286000" y="2304288"/>
-            <a:ext cx="1589684" cy="146304"/>
+            <a:off x="2514600" y="2304288"/>
+            <a:ext cx="1381201" cy="146304"/>
           </a:xfrm>
           <a:prstGeom prst="rect">
             <a:avLst/>
@@ -17290,8 +17290,8 @@
         </p:nvSpPr>
         <p:spPr>
           <a:xfrm>
-            <a:off x="5166359" y="2276856"/>
-            <a:ext cx="548640" cy="201168"/>
+            <a:off x="4983479" y="2276856"/>
+            <a:ext cx="731520" cy="201168"/>
           </a:xfrm>
           <a:prstGeom prst="rect">
             <a:avLst/>
@@ -17326,7 +17326,7 @@
         <p:spPr>
           <a:xfrm>
             <a:off x="713232" y="2670048"/>
-            <a:ext cx="1554480" cy="237744"/>
+            <a:ext cx="1828800" cy="237744"/>
           </a:xfrm>
           <a:prstGeom prst="rect">
             <a:avLst/>
@@ -17341,7 +17341,7 @@
           <a:p>
             <a:pPr algn="l"/>
             <a:r>
-              <a:rPr sz="900" b="1">
+              <a:rPr sz="850" b="1">
                 <a:solidFill>
                   <a:srgbClr val="18212B"/>
                 </a:solidFill>
@@ -17360,8 +17360,8 @@
         </p:nvSpPr>
         <p:spPr>
           <a:xfrm>
-            <a:off x="2286000" y="2688336"/>
-            <a:ext cx="2788920" cy="146304"/>
+            <a:off x="2514600" y="2688336"/>
+            <a:ext cx="2423160" cy="146304"/>
           </a:xfrm>
           <a:prstGeom prst="rect">
             <a:avLst/>
@@ -17406,8 +17406,8 @@
         </p:nvSpPr>
         <p:spPr>
           <a:xfrm>
-            <a:off x="2286000" y="2688336"/>
-            <a:ext cx="1980133" cy="146304"/>
+            <a:off x="2514600" y="2688336"/>
+            <a:ext cx="1720443" cy="146304"/>
           </a:xfrm>
           <a:prstGeom prst="rect">
             <a:avLst/>
@@ -17452,8 +17452,8 @@
         </p:nvSpPr>
         <p:spPr>
           <a:xfrm>
-            <a:off x="5166359" y="2660904"/>
-            <a:ext cx="548640" cy="201168"/>
+            <a:off x="4983479" y="2660904"/>
+            <a:ext cx="731520" cy="201168"/>
           </a:xfrm>
           <a:prstGeom prst="rect">
             <a:avLst/>
@@ -17542,7 +17542,7 @@
         <p:spPr>
           <a:xfrm>
             <a:off x="713232" y="4096512"/>
-            <a:ext cx="1554480" cy="237744"/>
+            <a:ext cx="1828800" cy="237744"/>
           </a:xfrm>
           <a:prstGeom prst="rect">
             <a:avLst/>
@@ -17557,7 +17557,7 @@
           <a:p>
             <a:pPr algn="l"/>
             <a:r>
-              <a:rPr sz="900" b="1">
+              <a:rPr sz="850" b="1">
                 <a:solidFill>
                   <a:srgbClr val="18212B"/>
                 </a:solidFill>
@@ -17576,8 +17576,8 @@
         </p:nvSpPr>
         <p:spPr>
           <a:xfrm>
-            <a:off x="2286000" y="4114800"/>
-            <a:ext cx="2788920" cy="146304"/>
+            <a:off x="2514600" y="4114800"/>
+            <a:ext cx="2423160" cy="146304"/>
           </a:xfrm>
           <a:prstGeom prst="rect">
             <a:avLst/>
@@ -17622,8 +17622,8 @@
         </p:nvSpPr>
         <p:spPr>
           <a:xfrm>
-            <a:off x="2286000" y="4114800"/>
-            <a:ext cx="1255014" cy="146304"/>
+            <a:off x="2514600" y="4114800"/>
+            <a:ext cx="1090422" cy="146304"/>
           </a:xfrm>
           <a:prstGeom prst="rect">
             <a:avLst/>
@@ -17668,8 +17668,8 @@
         </p:nvSpPr>
         <p:spPr>
           <a:xfrm>
-            <a:off x="5166359" y="4087368"/>
-            <a:ext cx="548640" cy="201168"/>
+            <a:off x="4983479" y="4087368"/>
+            <a:ext cx="731520" cy="201168"/>
           </a:xfrm>
           <a:prstGeom prst="rect">
             <a:avLst/>
@@ -17704,7 +17704,7 @@
         <p:spPr>
           <a:xfrm>
             <a:off x="713232" y="4480560"/>
-            <a:ext cx="1554480" cy="237744"/>
+            <a:ext cx="1828800" cy="237744"/>
           </a:xfrm>
           <a:prstGeom prst="rect">
             <a:avLst/>
@@ -17719,7 +17719,7 @@
           <a:p>
             <a:pPr algn="l"/>
             <a:r>
-              <a:rPr sz="900" b="1">
+              <a:rPr sz="850" b="1">
                 <a:solidFill>
                   <a:srgbClr val="18212B"/>
                 </a:solidFill>
@@ -17738,8 +17738,8 @@
         </p:nvSpPr>
         <p:spPr>
           <a:xfrm>
-            <a:off x="2286000" y="4498848"/>
-            <a:ext cx="2788920" cy="146304"/>
+            <a:off x="2514600" y="4498848"/>
+            <a:ext cx="2423160" cy="146304"/>
           </a:xfrm>
           <a:prstGeom prst="rect">
             <a:avLst/>
@@ -17784,8 +17784,8 @@
         </p:nvSpPr>
         <p:spPr>
           <a:xfrm>
-            <a:off x="2286000" y="4498848"/>
-            <a:ext cx="836676" cy="146304"/>
+            <a:off x="2514600" y="4498848"/>
+            <a:ext cx="726948" cy="146304"/>
           </a:xfrm>
           <a:prstGeom prst="rect">
             <a:avLst/>
@@ -17830,8 +17830,8 @@
         </p:nvSpPr>
         <p:spPr>
           <a:xfrm>
-            <a:off x="5166359" y="4471416"/>
-            <a:ext cx="548640" cy="201168"/>
+            <a:off x="4983479" y="4471416"/>
+            <a:ext cx="731520" cy="201168"/>
           </a:xfrm>
           <a:prstGeom prst="rect">
             <a:avLst/>
@@ -17866,7 +17866,7 @@
         <p:spPr>
           <a:xfrm>
             <a:off x="713232" y="4864608"/>
-            <a:ext cx="1554480" cy="237744"/>
+            <a:ext cx="1828800" cy="237744"/>
           </a:xfrm>
           <a:prstGeom prst="rect">
             <a:avLst/>
@@ -17881,7 +17881,7 @@
           <a:p>
             <a:pPr algn="l"/>
             <a:r>
-              <a:rPr sz="900" b="1">
+              <a:rPr sz="850" b="1">
                 <a:solidFill>
                   <a:srgbClr val="18212B"/>
                 </a:solidFill>
@@ -17900,8 +17900,8 @@
         </p:nvSpPr>
         <p:spPr>
           <a:xfrm>
-            <a:off x="2286000" y="4882896"/>
-            <a:ext cx="2788920" cy="146304"/>
+            <a:off x="2514600" y="4882896"/>
+            <a:ext cx="2423160" cy="146304"/>
           </a:xfrm>
           <a:prstGeom prst="rect">
             <a:avLst/>
@@ -17946,8 +17946,8 @@
         </p:nvSpPr>
         <p:spPr>
           <a:xfrm>
-            <a:off x="2286000" y="4882896"/>
-            <a:ext cx="1924354" cy="146304"/>
+            <a:off x="2514600" y="4882896"/>
+            <a:ext cx="1671980" cy="146304"/>
           </a:xfrm>
           <a:prstGeom prst="rect">
             <a:avLst/>
@@ -17992,8 +17992,8 @@
         </p:nvSpPr>
         <p:spPr>
           <a:xfrm>
-            <a:off x="5166359" y="4855464"/>
-            <a:ext cx="548640" cy="201168"/>
+            <a:off x="4983479" y="4855464"/>
+            <a:ext cx="731520" cy="201168"/>
           </a:xfrm>
           <a:prstGeom prst="rect">
             <a:avLst/>
@@ -19939,7 +19939,7 @@
         <p:spPr>
           <a:xfrm>
             <a:off x="6382512" y="1764792"/>
-            <a:ext cx="1554480" cy="237744"/>
+            <a:ext cx="1828800" cy="237744"/>
           </a:xfrm>
           <a:prstGeom prst="rect">
             <a:avLst/>
@@ -19954,7 +19954,7 @@
           <a:p>
             <a:pPr algn="l"/>
             <a:r>
-              <a:rPr sz="900" b="1">
+              <a:rPr sz="850" b="1">
                 <a:solidFill>
                   <a:srgbClr val="18212B"/>
                 </a:solidFill>
@@ -19973,8 +19973,8 @@
         </p:nvSpPr>
         <p:spPr>
           <a:xfrm>
-            <a:off x="7955279" y="1783080"/>
-            <a:ext cx="2606039" cy="146304"/>
+            <a:off x="8183879" y="1783080"/>
+            <a:ext cx="2240279" cy="146304"/>
           </a:xfrm>
           <a:prstGeom prst="rect">
             <a:avLst/>
@@ -20019,8 +20019,8 @@
         </p:nvSpPr>
         <p:spPr>
           <a:xfrm>
-            <a:off x="7955279" y="1783080"/>
-            <a:ext cx="2397556" cy="146304"/>
+            <a:off x="8183879" y="1783080"/>
+            <a:ext cx="2061057" cy="146304"/>
           </a:xfrm>
           <a:prstGeom prst="rect">
             <a:avLst/>
@@ -20065,8 +20065,8 @@
         </p:nvSpPr>
         <p:spPr>
           <a:xfrm>
-            <a:off x="10652759" y="1755648"/>
-            <a:ext cx="548640" cy="201168"/>
+            <a:off x="10469880" y="1755648"/>
+            <a:ext cx="731520" cy="201168"/>
           </a:xfrm>
           <a:prstGeom prst="rect">
             <a:avLst/>
@@ -20101,7 +20101,7 @@
         <p:spPr>
           <a:xfrm>
             <a:off x="6382512" y="2148840"/>
-            <a:ext cx="1554480" cy="237744"/>
+            <a:ext cx="1828800" cy="237744"/>
           </a:xfrm>
           <a:prstGeom prst="rect">
             <a:avLst/>
@@ -20116,7 +20116,7 @@
           <a:p>
             <a:pPr algn="l"/>
             <a:r>
-              <a:rPr sz="900" b="1">
+              <a:rPr sz="850" b="1">
                 <a:solidFill>
                   <a:srgbClr val="18212B"/>
                 </a:solidFill>
@@ -20135,8 +20135,8 @@
         </p:nvSpPr>
         <p:spPr>
           <a:xfrm>
-            <a:off x="7955279" y="2167128"/>
-            <a:ext cx="2606039" cy="146304"/>
+            <a:off x="8183879" y="2167128"/>
+            <a:ext cx="2240279" cy="146304"/>
           </a:xfrm>
           <a:prstGeom prst="rect">
             <a:avLst/>
@@ -20181,8 +20181,8 @@
         </p:nvSpPr>
         <p:spPr>
           <a:xfrm>
-            <a:off x="7955279" y="2167128"/>
-            <a:ext cx="1047628" cy="146304"/>
+            <a:off x="8183879" y="2167128"/>
+            <a:ext cx="900592" cy="146304"/>
           </a:xfrm>
           <a:prstGeom prst="rect">
             <a:avLst/>
@@ -20227,8 +20227,8 @@
         </p:nvSpPr>
         <p:spPr>
           <a:xfrm>
-            <a:off x="10652759" y="2139696"/>
-            <a:ext cx="548640" cy="201168"/>
+            <a:off x="10469880" y="2139696"/>
+            <a:ext cx="731520" cy="201168"/>
           </a:xfrm>
           <a:prstGeom prst="rect">
             <a:avLst/>
@@ -20263,7 +20263,7 @@
         <p:spPr>
           <a:xfrm>
             <a:off x="6382512" y="2532888"/>
-            <a:ext cx="1554480" cy="237744"/>
+            <a:ext cx="1828800" cy="237744"/>
           </a:xfrm>
           <a:prstGeom prst="rect">
             <a:avLst/>
@@ -20278,7 +20278,7 @@
           <a:p>
             <a:pPr algn="l"/>
             <a:r>
-              <a:rPr sz="900" b="1">
+              <a:rPr sz="850" b="1">
                 <a:solidFill>
                   <a:srgbClr val="18212B"/>
                 </a:solidFill>
@@ -20297,8 +20297,8 @@
         </p:nvSpPr>
         <p:spPr>
           <a:xfrm>
-            <a:off x="7955279" y="2551176"/>
-            <a:ext cx="2606039" cy="146304"/>
+            <a:off x="8183879" y="2551176"/>
+            <a:ext cx="2240279" cy="146304"/>
           </a:xfrm>
           <a:prstGeom prst="rect">
             <a:avLst/>
@@ -20343,8 +20343,8 @@
         </p:nvSpPr>
         <p:spPr>
           <a:xfrm>
-            <a:off x="7955279" y="2551176"/>
-            <a:ext cx="198059" cy="146304"/>
+            <a:off x="8183879" y="2551176"/>
+            <a:ext cx="170261" cy="146304"/>
           </a:xfrm>
           <a:prstGeom prst="rect">
             <a:avLst/>
@@ -20389,8 +20389,8 @@
         </p:nvSpPr>
         <p:spPr>
           <a:xfrm>
-            <a:off x="10652759" y="2523744"/>
-            <a:ext cx="548640" cy="201168"/>
+            <a:off x="10469880" y="2523744"/>
+            <a:ext cx="731520" cy="201168"/>
           </a:xfrm>
           <a:prstGeom prst="rect">
             <a:avLst/>
@@ -20425,7 +20425,7 @@
         <p:spPr>
           <a:xfrm>
             <a:off x="6382512" y="2916936"/>
-            <a:ext cx="1554480" cy="237744"/>
+            <a:ext cx="1828800" cy="237744"/>
           </a:xfrm>
           <a:prstGeom prst="rect">
             <a:avLst/>
@@ -20440,7 +20440,7 @@
           <a:p>
             <a:pPr algn="l"/>
             <a:r>
-              <a:rPr sz="900" b="1">
+              <a:rPr sz="850" b="1">
                 <a:solidFill>
                   <a:srgbClr val="18212B"/>
                 </a:solidFill>
@@ -20459,8 +20459,8 @@
         </p:nvSpPr>
         <p:spPr>
           <a:xfrm>
-            <a:off x="7955279" y="2935224"/>
-            <a:ext cx="2606039" cy="146304"/>
+            <a:off x="8183879" y="2935224"/>
+            <a:ext cx="2240279" cy="146304"/>
           </a:xfrm>
           <a:prstGeom prst="rect">
             <a:avLst/>
@@ -20505,8 +20505,8 @@
         </p:nvSpPr>
         <p:spPr>
           <a:xfrm>
-            <a:off x="7955279" y="2935224"/>
-            <a:ext cx="828720" cy="146304"/>
+            <a:off x="8183879" y="2935224"/>
+            <a:ext cx="712409" cy="146304"/>
           </a:xfrm>
           <a:prstGeom prst="rect">
             <a:avLst/>
@@ -20551,8 +20551,8 @@
         </p:nvSpPr>
         <p:spPr>
           <a:xfrm>
-            <a:off x="10652759" y="2907792"/>
-            <a:ext cx="548640" cy="201168"/>
+            <a:off x="10469880" y="2907792"/>
+            <a:ext cx="731520" cy="201168"/>
           </a:xfrm>
           <a:prstGeom prst="rect">
             <a:avLst/>
@@ -20641,7 +20641,7 @@
         <p:spPr>
           <a:xfrm>
             <a:off x="6382512" y="4187952"/>
-            <a:ext cx="1554480" cy="237744"/>
+            <a:ext cx="1828800" cy="237744"/>
           </a:xfrm>
           <a:prstGeom prst="rect">
             <a:avLst/>
@@ -20656,7 +20656,7 @@
           <a:p>
             <a:pPr algn="l"/>
             <a:r>
-              <a:rPr sz="900" b="1">
+              <a:rPr sz="850" b="1">
                 <a:solidFill>
                   <a:srgbClr val="18212B"/>
                 </a:solidFill>
@@ -20675,8 +20675,8 @@
         </p:nvSpPr>
         <p:spPr>
           <a:xfrm>
-            <a:off x="7955279" y="4206240"/>
-            <a:ext cx="2606039" cy="146304"/>
+            <a:off x="8183879" y="4206240"/>
+            <a:ext cx="2240279" cy="146304"/>
           </a:xfrm>
           <a:prstGeom prst="rect">
             <a:avLst/>
@@ -20721,8 +20721,8 @@
         </p:nvSpPr>
         <p:spPr>
           <a:xfrm>
-            <a:off x="7955279" y="4206240"/>
-            <a:ext cx="1615744" cy="146304"/>
+            <a:off x="8183879" y="4206240"/>
+            <a:ext cx="1388973" cy="146304"/>
           </a:xfrm>
           <a:prstGeom prst="rect">
             <a:avLst/>
@@ -20767,8 +20767,8 @@
         </p:nvSpPr>
         <p:spPr>
           <a:xfrm>
-            <a:off x="10652759" y="4178807"/>
-            <a:ext cx="548640" cy="201168"/>
+            <a:off x="10469880" y="4178807"/>
+            <a:ext cx="731520" cy="201168"/>
           </a:xfrm>
           <a:prstGeom prst="rect">
             <a:avLst/>
@@ -20803,7 +20803,7 @@
         <p:spPr>
           <a:xfrm>
             <a:off x="6382512" y="4572000"/>
-            <a:ext cx="1554480" cy="237744"/>
+            <a:ext cx="1828800" cy="237744"/>
           </a:xfrm>
           <a:prstGeom prst="rect">
             <a:avLst/>
@@ -20818,7 +20818,7 @@
           <a:p>
             <a:pPr algn="l"/>
             <a:r>
-              <a:rPr sz="900" b="1">
+              <a:rPr sz="850" b="1">
                 <a:solidFill>
                   <a:srgbClr val="18212B"/>
                 </a:solidFill>
@@ -20837,8 +20837,8 @@
         </p:nvSpPr>
         <p:spPr>
           <a:xfrm>
-            <a:off x="7955279" y="4590288"/>
-            <a:ext cx="2606039" cy="146304"/>
+            <a:off x="8183879" y="4590288"/>
+            <a:ext cx="2240279" cy="146304"/>
           </a:xfrm>
           <a:prstGeom prst="rect">
             <a:avLst/>
@@ -20883,8 +20883,8 @@
         </p:nvSpPr>
         <p:spPr>
           <a:xfrm>
-            <a:off x="7955279" y="4590288"/>
-            <a:ext cx="1104960" cy="146304"/>
+            <a:off x="8183879" y="4590288"/>
+            <a:ext cx="949878" cy="146304"/>
           </a:xfrm>
           <a:prstGeom prst="rect">
             <a:avLst/>
@@ -20929,8 +20929,8 @@
         </p:nvSpPr>
         <p:spPr>
           <a:xfrm>
-            <a:off x="10652759" y="4562855"/>
-            <a:ext cx="548640" cy="201168"/>
+            <a:off x="10469880" y="4562855"/>
+            <a:ext cx="731520" cy="201168"/>
           </a:xfrm>
           <a:prstGeom prst="rect">
             <a:avLst/>
@@ -20965,7 +20965,7 @@
         <p:spPr>
           <a:xfrm>
             <a:off x="6382512" y="4956048"/>
-            <a:ext cx="1554480" cy="237744"/>
+            <a:ext cx="1828800" cy="237744"/>
           </a:xfrm>
           <a:prstGeom prst="rect">
             <a:avLst/>
@@ -20980,7 +20980,7 @@
           <a:p>
             <a:pPr algn="l"/>
             <a:r>
-              <a:rPr sz="900" b="1">
+              <a:rPr sz="850" b="1">
                 <a:solidFill>
                   <a:srgbClr val="18212B"/>
                 </a:solidFill>
@@ -20999,8 +20999,8 @@
         </p:nvSpPr>
         <p:spPr>
           <a:xfrm>
-            <a:off x="7955279" y="4974336"/>
-            <a:ext cx="2606039" cy="146304"/>
+            <a:off x="8183879" y="4974336"/>
+            <a:ext cx="2240279" cy="146304"/>
           </a:xfrm>
           <a:prstGeom prst="rect">
             <a:avLst/>
@@ -21045,8 +21045,8 @@
         </p:nvSpPr>
         <p:spPr>
           <a:xfrm>
-            <a:off x="7955279" y="4974336"/>
-            <a:ext cx="1675683" cy="146304"/>
+            <a:off x="8183879" y="4974336"/>
+            <a:ext cx="1440500" cy="146304"/>
           </a:xfrm>
           <a:prstGeom prst="rect">
             <a:avLst/>
@@ -21091,8 +21091,8 @@
         </p:nvSpPr>
         <p:spPr>
           <a:xfrm>
-            <a:off x="10652759" y="4946903"/>
-            <a:ext cx="548640" cy="201168"/>
+            <a:off x="10469880" y="4946903"/>
+            <a:ext cx="731520" cy="201168"/>
           </a:xfrm>
           <a:prstGeom prst="rect">
             <a:avLst/>
@@ -21127,7 +21127,7 @@
         <p:spPr>
           <a:xfrm>
             <a:off x="6382512" y="5340096"/>
-            <a:ext cx="1554480" cy="237744"/>
+            <a:ext cx="1828800" cy="237744"/>
           </a:xfrm>
           <a:prstGeom prst="rect">
             <a:avLst/>
@@ -21142,7 +21142,7 @@
           <a:p>
             <a:pPr algn="l"/>
             <a:r>
-              <a:rPr sz="900" b="1">
+              <a:rPr sz="850" b="1">
                 <a:solidFill>
                   <a:srgbClr val="18212B"/>
                 </a:solidFill>
@@ -21161,8 +21161,8 @@
         </p:nvSpPr>
         <p:spPr>
           <a:xfrm>
-            <a:off x="7955279" y="5358383"/>
-            <a:ext cx="2606039" cy="146304"/>
+            <a:off x="8183879" y="5358383"/>
+            <a:ext cx="2240279" cy="146304"/>
           </a:xfrm>
           <a:prstGeom prst="rect">
             <a:avLst/>
@@ -21207,8 +21207,8 @@
         </p:nvSpPr>
         <p:spPr>
           <a:xfrm>
-            <a:off x="7955279" y="5358383"/>
-            <a:ext cx="1563623" cy="146304"/>
+            <a:off x="8183879" y="5358383"/>
+            <a:ext cx="1344167" cy="146304"/>
           </a:xfrm>
           <a:prstGeom prst="rect">
             <a:avLst/>
@@ -21253,8 +21253,8 @@
         </p:nvSpPr>
         <p:spPr>
           <a:xfrm>
-            <a:off x="10652759" y="5330951"/>
-            <a:ext cx="548640" cy="201168"/>
+            <a:off x="10469880" y="5330951"/>
+            <a:ext cx="731520" cy="201168"/>
           </a:xfrm>
           <a:prstGeom prst="rect">
             <a:avLst/>

</xml_diff>